<commit_message>
content(fifty-states): semitruckmatch 2026-06-02T12 UTC
</commit_message>
<xml_diff>
--- a/public/blog/presentations/18-wheeler-crash-in-charlotte-north-carolina-victim-guide-2026.pptx
+++ b/public/blog/presentations/18-wheeler-crash-in-charlotte-north-carolina-victim-guide-2026.pptx
@@ -17,6 +17,8 @@
     <p:sldId id="265" r:id="rId17"/>
     <p:sldId id="266" r:id="rId18"/>
     <p:sldId id="267" r:id="rId19"/>
+    <p:sldId id="268" r:id="rId20"/>
+    <p:sldId id="269" r:id="rId21"/>
   </p:sldIdLst>
   <p:sldSz cx="9144000" cy="6858000" type="screen4x3"/>
   <p:notesSz cx="6858000" cy="9144000"/>
@@ -513,7 +515,7 @@
           <a:lstStyle/>
           <a:p>
             <a:r>
-              <a:t>Educational presentation for 18-Wheeler Crash in Charlotte, North Carolina — Victim Guide (2026). Full guide: https://www.wreckmatch.com/blog/18-wheeler-crash-in-charlotte-north-carolina-victim-guide-2026. WreckMatch LLC legal referral service, not a law firm. WreckMatch LLC — legal referral service, not a law firm. Educational only. 800+ participating law firms. Call 855 WRECKMATCH. Reviewed for legal context by Judge Roy Waddell.</a:t>
+              <a:t>Educational presentation for 18-Wheeler Crash in Charlotte, North Carolina — Victim Guide (2026). Full guide: https://www.wreckmatch.com/blog/18-wheeler-crash-in-charlotte-north-carolina-victim-guide-2026. WreckMatch LLC legal referral service, not a law firm. WreckMatch LLC — legal referral service, not a law firm. Educational only. 800+ participating law firms. Call 855 WRECKMATCH. Reviewed for legal context by Hon. Ret. Judge Roy Waddell.</a:t>
             </a:r>
           </a:p>
         </p:txBody>
@@ -583,7 +585,29 @@
           <a:lstStyle/>
           <a:p>
             <a:r>
-              <a:t>Frequently asked questions WreckMatch LLC — legal referral service, not a law firm. Educational only. 800+ participating law firms. Call 855 WRECKMATCH. Reviewed for legal context by Judge Roy Waddell.</a:t>
+              <a:t>Is SemiTruckMatch a law firm? — No. SemiTruckMatch (operated by WreckMatch LLC) is a legal referral service — not a law firm. We connect injured people with participating attorneys who handle truck and catastrophic injury cases in North Carolina. How fast is the callback? — Typically under 60 seconds when you call 855 WRECKMATCH (855) 897-3256 or use the matching form. What if I cannot afford a lawyer? — Participating attorneys usually work on contingency — no upfront fee for representation; fees are agreed in writing if they recover compensation for you. Where is the local help hub? — Charlotte truck accident help · National truck crash guide</a:t>
+            </a:r>
+          </a:p>
+          <a:p/>
+          <a:p/>
+          <a:p>
+            <a:r>
+              <a:t>Reviewed for legal context by Hon. Ret. Judge Roy Waddell, Legal Advisor at WreckMatch LLC — courtroom and procedural perspective only; not legal advice for your specific case.</a:t>
+            </a:r>
+          </a:p>
+          <a:p/>
+          <a:p/>
+          <a:p>
+            <a:r>
+              <a:t>Free attorney matching → · 855 WRECKMATCH (855) 897-3256</a:t>
+            </a:r>
+          </a:p>
+          <a:p/>
+          <a:p/>
+          <a:p/>
+          <a:p>
+            <a:r>
+              <a:t>At a glance: North Carolina fast facts: 3-year statute of limitations · Contributory fault rule · 30/60/25 minimum auto liability insurance. WreckMatch LLC — legal referral service, not a law firm. Educational only. 800+ participating law firms. Call 855 WRECKMATCH. Reviewed for legal context by Hon. Ret. Judge Roy Waddell.</a:t>
             </a:r>
           </a:p>
         </p:txBody>
@@ -653,7 +677,19 @@
           <a:lstStyle/>
           <a:p>
             <a:r>
-              <a:t>Get matched with a licensed attorney WreckMatch LLC — legal referral service, not a law firm. Educational only. 800+ participating law firms. Call 855 WRECKMATCH. Reviewed for legal context by Judge Roy Waddell.</a:t>
+              <a:t>In North Carolina, the statute of limitations on most personal-injury claims is 3 years from the date of the crash. Missing that window almost always ends the case — courts dismiss late-filed lawsuits with rare exceptions for minors, mental incapacity, or delayed discovery of injuries. Notice deadlines for claims against government vehicles can be far shorter, sometimes 60 to 180 days.</a:t>
+            </a:r>
+          </a:p>
+          <a:p/>
+          <a:p>
+            <a:r>
+              <a:t>North Carolina follows the Contributory rule for fault allocation. Under traditional contributory negligence, if you are even 1% at fault you can be barred from recovering anything — one of the harshest rules in the country. That makes the on-scene evidence collection in the first 48 hours unusually important. The minimum liability insurance every driver must carry in North Carolina is 30/60/25 (bodily injury per person / per accident / property damage). For serious crashes those minimums are routinely exhausted in days, which is why uninsured/underinsured-motorist (UM/UIM) coverage on your own policy matters so much.</a:t>
+            </a:r>
+          </a:p>
+          <a:p/>
+          <a:p>
+            <a:r>
+              <a:t>North Carolina is an at-fault state. The at-fault driver's liability insurance is the primary source of recovery, and you can pursue compensation for medical bills, lost wages, and pa WreckMatch LLC — legal referral service, not a law firm. Educational only. 800+ participating law firms. Call 855 WRECKMATCH. Reviewed for legal context by Hon. Ret. Judge Roy Waddell.</a:t>
             </a:r>
           </a:p>
         </p:txBody>
@@ -723,7 +759,147 @@
           <a:lstStyle/>
           <a:p>
             <a:r>
-              <a:t>Reviewed for legal context WreckMatch LLC — legal referral service, not a law firm. Educational only. 800+ participating law firms. Call 855 WRECKMATCH. Reviewed for legal context by Judge Roy Waddell.</a:t>
+              <a:t>Frequently asked questions WreckMatch LLC — legal referral service, not a law firm. Educational only. 800+ participating law firms. Call 855 WRECKMATCH. Reviewed for legal context by Hon. Ret. Judge Roy Waddell.</a:t>
+            </a:r>
+          </a:p>
+        </p:txBody>
+      </p:sp>
+      <p:sp>
+        <p:nvSpPr>
+          <p:cNvPr id="4" name="Slide Number Placeholder 3"/>
+          <p:cNvSpPr>
+            <a:spLocks noGrp="1"/>
+          </p:cNvSpPr>
+          <p:nvPr>
+            <p:ph type="sldNum" idx="5" sz="quarter"/>
+          </p:nvPr>
+        </p:nvSpPr>
+        <p:spPr/>
+      </p:sp>
+    </p:spTree>
+  </p:cSld>
+  <p:clrMapOvr>
+    <a:masterClrMapping/>
+  </p:clrMapOvr>
+</p:notes>
+</file>
+
+<file path=ppt/notesSlides/notesSlide13.xml><?xml version="1.0" encoding="utf-8"?>
+<p:notes xmlns:a="http://schemas.openxmlformats.org/drawingml/2006/main" xmlns:p="http://schemas.openxmlformats.org/presentationml/2006/main" xmlns:r="http://schemas.openxmlformats.org/officeDocument/2006/relationships">
+  <p:cSld>
+    <p:spTree>
+      <p:nvGrpSpPr>
+        <p:cNvPr id="1" name=""/>
+        <p:cNvGrpSpPr/>
+        <p:nvPr/>
+      </p:nvGrpSpPr>
+      <p:grpSpPr>
+        <a:xfrm>
+          <a:off x="0" y="0"/>
+          <a:ext cx="0" cy="0"/>
+          <a:chOff x="0" y="0"/>
+          <a:chExt cx="0" cy="0"/>
+        </a:xfrm>
+      </p:grpSpPr>
+      <p:sp>
+        <p:nvSpPr>
+          <p:cNvPr id="2" name="Slide Image Placeholder 1"/>
+          <p:cNvSpPr>
+            <a:spLocks noGrp="1"/>
+          </p:cNvSpPr>
+          <p:nvPr>
+            <p:ph type="sldImg" idx="2"/>
+          </p:nvPr>
+        </p:nvSpPr>
+        <p:spPr/>
+      </p:sp>
+      <p:sp>
+        <p:nvSpPr>
+          <p:cNvPr id="3" name="Notes Placeholder 2"/>
+          <p:cNvSpPr>
+            <a:spLocks noGrp="1"/>
+          </p:cNvSpPr>
+          <p:nvPr>
+            <p:ph type="body" idx="3" sz="quarter"/>
+          </p:nvPr>
+        </p:nvSpPr>
+        <p:spPr/>
+        <p:txBody>
+          <a:bodyPr/>
+          <a:lstStyle/>
+          <a:p>
+            <a:r>
+              <a:t>Get matched with a licensed attorney WreckMatch LLC — legal referral service, not a law firm. Educational only. 800+ participating law firms. Call 855 WRECKMATCH. Reviewed for legal context by Hon. Ret. Judge Roy Waddell.</a:t>
+            </a:r>
+          </a:p>
+        </p:txBody>
+      </p:sp>
+      <p:sp>
+        <p:nvSpPr>
+          <p:cNvPr id="4" name="Slide Number Placeholder 3"/>
+          <p:cNvSpPr>
+            <a:spLocks noGrp="1"/>
+          </p:cNvSpPr>
+          <p:nvPr>
+            <p:ph type="sldNum" idx="5" sz="quarter"/>
+          </p:nvPr>
+        </p:nvSpPr>
+        <p:spPr/>
+      </p:sp>
+    </p:spTree>
+  </p:cSld>
+  <p:clrMapOvr>
+    <a:masterClrMapping/>
+  </p:clrMapOvr>
+</p:notes>
+</file>
+
+<file path=ppt/notesSlides/notesSlide14.xml><?xml version="1.0" encoding="utf-8"?>
+<p:notes xmlns:a="http://schemas.openxmlformats.org/drawingml/2006/main" xmlns:p="http://schemas.openxmlformats.org/presentationml/2006/main" xmlns:r="http://schemas.openxmlformats.org/officeDocument/2006/relationships">
+  <p:cSld>
+    <p:spTree>
+      <p:nvGrpSpPr>
+        <p:cNvPr id="1" name=""/>
+        <p:cNvGrpSpPr/>
+        <p:nvPr/>
+      </p:nvGrpSpPr>
+      <p:grpSpPr>
+        <a:xfrm>
+          <a:off x="0" y="0"/>
+          <a:ext cx="0" cy="0"/>
+          <a:chOff x="0" y="0"/>
+          <a:chExt cx="0" cy="0"/>
+        </a:xfrm>
+      </p:grpSpPr>
+      <p:sp>
+        <p:nvSpPr>
+          <p:cNvPr id="2" name="Slide Image Placeholder 1"/>
+          <p:cNvSpPr>
+            <a:spLocks noGrp="1"/>
+          </p:cNvSpPr>
+          <p:nvPr>
+            <p:ph type="sldImg" idx="2"/>
+          </p:nvPr>
+        </p:nvSpPr>
+        <p:spPr/>
+      </p:sp>
+      <p:sp>
+        <p:nvSpPr>
+          <p:cNvPr id="3" name="Notes Placeholder 2"/>
+          <p:cNvSpPr>
+            <a:spLocks noGrp="1"/>
+          </p:cNvSpPr>
+          <p:nvPr>
+            <p:ph type="body" idx="3" sz="quarter"/>
+          </p:nvPr>
+        </p:nvSpPr>
+        <p:spPr/>
+        <p:txBody>
+          <a:bodyPr/>
+          <a:lstStyle/>
+          <a:p>
+            <a:r>
+              <a:t>Reviewed for legal context WreckMatch LLC — legal referral service, not a law firm. Educational only. 800+ participating law firms. Call 855 WRECKMATCH. Reviewed for legal context by Hon. Ret. Judge Roy Waddell.</a:t>
             </a:r>
           </a:p>
         </p:txBody>
@@ -793,7 +969,7 @@
           <a:lstStyle/>
           <a:p>
             <a:r>
-              <a:t>Important — read first WreckMatch LLC — legal referral service, not a law firm. Educational only. 800+ participating law firms. Call 855 WRECKMATCH. Reviewed for legal context by Judge Roy Waddell.</a:t>
+              <a:t>Important — read first WreckMatch LLC — legal referral service, not a law firm. Educational only. 800+ participating law firms. Call 855 WRECKMATCH. Reviewed for legal context by Hon. Ret. Judge Roy Waddell.</a:t>
             </a:r>
           </a:p>
         </p:txBody>
@@ -863,7 +1039,7 @@
           <a:lstStyle/>
           <a:p>
             <a:r>
-              <a:t>After a semi truck or crash in Charlotte, call 911, get trauma care, preserve evidence including ECM/black box data, avoid recorded insurer statements, and use free attorney matching before signing anything. WreckMatch LLC — legal referral service, not a law firm. Educational only. 800+ participating law firms. Call 855 WRECKMATCH. Reviewed for legal context by Judge Roy Waddell.</a:t>
+              <a:t>After a semi truck or crash in Charlotte, North Carolina, call 911, get medical care, preserve evidence including ECM/black box and carrier IDs, avoid recorded insurer statements, and use free attorney matching before signing anything. WreckMatch LLC — legal referral service, not a law firm. Educational only. 800+ participating law firms. Call 855 WRECKMATCH. Reviewed for legal context by Hon. Ret. Judge Roy Waddell.</a:t>
             </a:r>
           </a:p>
         </p:txBody>
@@ -933,19 +1109,13 @@
           <a:lstStyle/>
           <a:p>
             <a:r>
-              <a:t>Insurance companies run billion-dollar playbooks the moment a crash is reported — trained adjusters, scripted calls, and pressure to settle before you understand your rights. Scott Tischler, Co-Founder of WreckMatch, built our AI intake and educational stack so everyday drivers in North Carolina are not outgunned. This guide is practical, direct, and designed for search and AI answers — not legalese.</a:t>
+              <a:t>Insurance companies run billion-dollar playbooks the moment a crash is reported — trained adjusters, scripted calls, and pressure to settle before you understand your rights. Scott Tischler, Co-Founder of WreckMatch, built our AI intake and educational stack so semi-truck crash victims in North Carolina are not outgunned. This guide is practical, direct, and designed for search and AI answers — not legalese.</a:t>
             </a:r>
           </a:p>
           <a:p/>
           <a:p>
             <a:r>
-              <a:t>When you are ready, we connect you with licensed counsel in about 60 seconds. WreckMatch is a referral service, not a law firm.</a:t>
-            </a:r>
-          </a:p>
-          <a:p/>
-          <a:p>
-            <a:r>
-              <a:t>Quick answer: After a semi truck or crash in Charlotte, call 911, get trauma care, preserve evidence including ECM/black box data, avoid recorded insurer statements, and use free attorney matching before signing anything. WreckMatch LLC — legal referral service, not a law firm. Educational only. 800+ participating law firms. Call 855 WRECKMATCH. Reviewed for legal context by Judge Roy Waddell.</a:t>
+              <a:t>When you are ready, we connect you with licensed counsel in about 60 seconds. SemiTruckMatch is a referral service, not a law firm. WreckMatch LLC — legal referral service, not a law firm. Educational only. 800+ participating law firms. Call 855 WRECKMATCH. Reviewed for legal context by Hon. Ret. Judge Roy Waddell.</a:t>
             </a:r>
           </a:p>
         </p:txBody>
@@ -1015,22 +1185,22 @@
           <a:lstStyle/>
           <a:p>
             <a:r>
-              <a:t>1. Call 911 — truck crashes often need highway patrol + EMS.</a:t>
-            </a:r>
-          </a:p>
-          <a:p>
-            <a:r>
-              <a:t>2. Photograph all vehicles, DOT numbers, plates, and scene marks.</a:t>
-            </a:r>
-          </a:p>
-          <a:p>
-            <a:r>
-              <a:t>3. Identify carrier name on the tractor/trailer door.</a:t>
-            </a:r>
-          </a:p>
-          <a:p>
-            <a:r>
-              <a:t>4. Seek trauma care — severe injuries may not show on X-ray day one.</a:t>
+              <a:t>1. Call 911 — commercial crashes often need highway patrol, HAZMAT, and EMS.</a:t>
+            </a:r>
+          </a:p>
+          <a:p>
+            <a:r>
+              <a:t>2. Photograph all units, DOT numbers, plates, carrier logos, and road conditions.</a:t>
+            </a:r>
+          </a:p>
+          <a:p>
+            <a:r>
+              <a:t>3. Request driver and carrier identification (many defendants may exist).</a:t>
+            </a:r>
+          </a:p>
+          <a:p>
+            <a:r>
+              <a:t>4. Seek trauma care — internal injuries are common even when you feel “fine.”</a:t>
             </a:r>
           </a:p>
           <a:p>
@@ -1040,7 +1210,7 @@
           </a:p>
           <a:p>
             <a:r>
-              <a:t>6. Get matched with a lawyer → WreckMatch LLC — legal referral service, not a law firm. Educational only. 800+ participating law firms. Call 855 WRECKMATCH. Reviewed for legal context by Judge Roy Waddell.</a:t>
+              <a:t>6. Get matched with a lawyer → WreckMatch LLC — legal referral service, not a law firm. Educational only. 800+ participating law firms. Call 855 WRECKMATCH. Reviewed for legal context by Hon. Ret. Judge Roy Waddell.</a:t>
             </a:r>
           </a:p>
         </p:txBody>
@@ -1141,7 +1311,7 @@
           <a:p/>
           <a:p>
             <a:r>
-              <a:t>Direct answer: Truck cases often involve multiple defendants (driver, carrier, broker). Preserve spoliation letters immediately. WreckMatch LLC — legal referral service, not a law firm. Educational only. 800+ participating law firms. Call 855 WRECKMATCH. Reviewed for legal context by Judge Roy Waddell.</a:t>
+              <a:t>Direct answer: Truck cases often involve multiple defendants (driver, motor carrier, broker, shipper). Your attorney may send spoliation letters immediately so electronic data is preserved. WreckMatch LLC — legal referral service, not a law firm. Educational only. 800+ participating law firms. Call 855 WRECKMATCH. Reviewed for legal context by Hon. Ret. Judge Roy Waddell.</a:t>
             </a:r>
           </a:p>
         </p:txBody>
@@ -1221,12 +1391,23 @@
           </a:p>
           <a:p>
             <a:r>
-              <a:t>| Statute of limitations | 3 years (most injury claims — confirm with licensed counsel) (many claims) |</a:t>
-            </a:r>
-          </a:p>
-          <a:p>
-            <a:r>
-              <a:t>| WreckMatch fee | $0 matching | WreckMatch LLC — legal referral service, not a law firm. Educational only. 800+ participating law firms. Call 855 WRECKMATCH. Reviewed for legal context by Judge Roy Waddell.</a:t>
+              <a:t>| Statute of limitations | 3 years (most injury claims — confirm with licensed counsel) |</a:t>
+            </a:r>
+          </a:p>
+          <a:p>
+            <a:r>
+              <a:t>| Government / special defendants | Often much shorter notice windows — ask counsel immediately |</a:t>
+            </a:r>
+          </a:p>
+          <a:p>
+            <a:r>
+              <a:t>| SemiTruckMatch matching fee | $0 to consumers |</a:t>
+            </a:r>
+          </a:p>
+          <a:p/>
+          <a:p>
+            <a:r>
+              <a:t>Insurers track filing deadlines closely. Missing a notice period can end a claim even when injuries are catastrophic. WreckMatch LLC — legal referral service, not a law firm. Educational only. 800+ participating law firms. Call 855 WRECKMATCH. Reviewed for legal context by Hon. Ret. Judge Roy Waddell.</a:t>
             </a:r>
           </a:p>
         </p:txBody>
@@ -1296,17 +1477,22 @@
           <a:lstStyle/>
           <a:p>
             <a:r>
-              <a:t>- Rushing low settlements before surgery/MRI results</a:t>
-            </a:r>
-          </a:p>
-          <a:p>
-            <a:r>
-              <a:t>- Disputing serious injury thresholds</a:t>
-            </a:r>
-          </a:p>
-          <a:p>
-            <a:r>
-              <a:t>- Multiple insurers pointing blame at each other (common in truck cases) WreckMatch LLC — legal referral service, not a law firm. Educational only. 800+ participating law firms. Call 855 WRECKMATCH. Reviewed for legal context by Judge Roy Waddell.</a:t>
+              <a:t>- Recorded statements in the first 24–48 hours designed to lock in fault language</a:t>
+            </a:r>
+          </a:p>
+          <a:p>
+            <a:r>
+              <a:t>- Quick cash offers before MRI results or specialist referrals return</a:t>
+            </a:r>
+          </a:p>
+          <a:p>
+            <a:r>
+              <a:t>- Disputing serious injury thresholds or pre-existing conditions</a:t>
+            </a:r>
+          </a:p>
+          <a:p>
+            <a:r>
+              <a:t>- Multiple policies pointing blame at each other (especially in truck and multi-vehicle crashes) WreckMatch LLC — legal referral service, not a law firm. Educational only. 800+ participating law firms. Call 855 WRECKMATCH. Reviewed for legal context by Hon. Ret. Judge Roy Waddell.</a:t>
             </a:r>
           </a:p>
         </p:txBody>
@@ -1376,19 +1562,7 @@
           <a:lstStyle/>
           <a:p>
             <a:r>
-              <a:t>Does WreckMatch have truck accident lawyers? — We refer to participating attorneys who handle car, truck, and catastrophic injury matters in North Carolina. How fast is callback? — Typically under 60 seconds at wreckmatch.com. Full Charlotte guide — Charlotte help hub</a:t>
-            </a:r>
-          </a:p>
-          <a:p/>
-          <a:p>
-            <a:r>
-              <a:t>Free attorney matching → · 855 WRECKMATCH (855) 897-3256</a:t>
-            </a:r>
-          </a:p>
-          <a:p/>
-          <a:p>
-            <a:r>
-              <a:t>--- WreckMatch LLC — legal referral service, not a law firm. Educational only. 800+ participating law firms. Call 855 WRECKMATCH. Reviewed for legal context by Judge Roy Waddell.</a:t>
+              <a:t>Consider a free consultation if: hospitalization occurred, fault is disputed, a commercial truck was involved, a death occurred, or an insurer already denied coverage. SemiTruckMatch connects you with participating licensed attorneys — we do not provide legal advice ourselves. WreckMatch LLC — legal referral service, not a law firm. Educational only. 800+ participating law firms. Call 855 WRECKMATCH. Reviewed for legal context by Hon. Ret. Judge Roy Waddell.</a:t>
             </a:r>
           </a:p>
         </p:txBody>
@@ -4482,7 +4656,7 @@
               </a:defRPr>
             </a:pPr>
             <a:r>
-              <a:t>Truck Accidents · North Carolina · 2026-05-23</a:t>
+              <a:t>Truck Accidents · North Carolina · 2026-06-02</a:t>
             </a:r>
           </a:p>
         </p:txBody>
@@ -4586,7 +4760,7 @@
               </a:defRPr>
             </a:pPr>
             <a:r>
-              <a:t>Frequently asked questions</a:t>
+              <a:t>FAQ</a:t>
             </a:r>
           </a:p>
         </p:txBody>
@@ -4624,7 +4798,7 @@
               </a:defRPr>
             </a:pPr>
             <a:r>
-              <a:t>Q: How long do I have to file a commercial-truck crash claim in North Carolina?</a:t>
+              <a:t>Q: Is SemiTruckMatch a law firm?</a:t>
             </a:r>
           </a:p>
           <a:p>
@@ -4639,7 +4813,7 @@
               </a:defRPr>
             </a:pPr>
             <a:r>
-              <a:t>A: North Carolina sets a 3-year statute of limitations for most personal-injury lawsuits arising from a commercial-truck crash, running from the date of the crash. Notice-of-claim deadlines against government vehicles are usually much shorter — sometimes 60 to 180 days — and minors and incapacitated plaintiffs may have tolled deadlines. Treat the headline number as a ceiling, not a target: file or co</a:t>
+              <a:t>A: No. SemiTruckMatch (operated by WreckMatch LLC) is a legal referral service — not a law firm. We connect injured people with participating attorneys who handle truck and catastrophic injury cases in North Carolina.</a:t>
             </a:r>
           </a:p>
           <a:p>
@@ -4654,7 +4828,7 @@
               </a:defRPr>
             </a:pPr>
             <a:r>
-              <a:t>Q: How much does it cost to talk to a WreckMatch-network attorney?</a:t>
+              <a:t>Q: How fast is the callback?</a:t>
             </a:r>
           </a:p>
           <a:p>
@@ -4669,7 +4843,7 @@
               </a:defRPr>
             </a:pPr>
             <a:r>
-              <a:t>A: Nothing up front. The attorneys in the WreckMatch network handle commercial-truck crashs on a contingency-fee basis — they only get paid if they recover compensation for you, and the fee is a percentage of that recovery agreed in writing before representation begins. The initial consultation is free, and there is no obligation to hire the attorney after the call. WreckMatch LLC itself is a legal r</a:t>
+              <a:t>A: Typically under 60 seconds when you call 855 WRECKMATCH (855) 897-3256 or use the matching form.</a:t>
             </a:r>
           </a:p>
           <a:p>
@@ -4684,7 +4858,7 @@
               </a:defRPr>
             </a:pPr>
             <a:r>
-              <a:t>Q: What if the other driver was uninsured or fled the scene?</a:t>
+              <a:t>Q: What if I cannot afford a lawyer?</a:t>
             </a:r>
           </a:p>
           <a:p>
@@ -4699,7 +4873,7 @@
               </a:defRPr>
             </a:pPr>
             <a:r>
-              <a:t>A: Roughly 1 in 8 U.S. drivers carries no insurance, and hit-and-run rates are climbing in major metros. If the at-fault driver was uninsured or fled, your own uninsured-motorist (UM) coverage is the primary source of recovery, assuming you carry it. Many drivers don't realize they have UM coverage until a lawyer reviews the declarations page of their policy. If UM is in place, the claim is filed aga</a:t>
+              <a:t>A: Participating attorneys usually work on contingency — no upfront fee for representation; fees are agreed in writing if they recover compensation for you.</a:t>
             </a:r>
           </a:p>
           <a:p>
@@ -4714,7 +4888,7 @@
               </a:defRPr>
             </a:pPr>
             <a:r>
-              <a:t>Q: Should I give the other driver's insurance a recorded statement?</a:t>
+              <a:t>Q: Where is the local help hub?</a:t>
             </a:r>
           </a:p>
         </p:txBody>
@@ -4818,7 +4992,7 @@
               </a:defRPr>
             </a:pPr>
             <a:r>
-              <a:t>Get matched with a licensed attorney</a:t>
+              <a:t>North Carolina legal context for commercial-truck crashs</a:t>
             </a:r>
           </a:p>
         </p:txBody>
@@ -4856,52 +5030,7 @@
               </a:defRPr>
             </a:pPr>
             <a:r>
-              <a:t>Free attorney matching in ~60 seconds: https://www.wreckmatch.com/#form</a:t>
-            </a:r>
-          </a:p>
-          <a:p>
-            <a:pPr>
-              <a:spcAft>
-                <a:spcPts val="800"/>
-              </a:spcAft>
-              <a:defRPr sz="1500">
-                <a:solidFill>
-                  <a:srgbClr val="94A3B8"/>
-                </a:solidFill>
-              </a:defRPr>
-            </a:pPr>
-            <a:r>
-              <a:t>Call 855 WRECKMATCH (855) 897-3256</a:t>
-            </a:r>
-          </a:p>
-          <a:p>
-            <a:pPr>
-              <a:spcAft>
-                <a:spcPts val="800"/>
-              </a:spcAft>
-              <a:defRPr sz="1500">
-                <a:solidFill>
-                  <a:srgbClr val="94A3B8"/>
-                </a:solidFill>
-              </a:defRPr>
-            </a:pPr>
-            <a:r>
-              <a:t>Full article: https://www.wreckmatch.com/blog/18-wheeler-crash-in-charlotte-north-carolina-victim-guide-2026</a:t>
-            </a:r>
-          </a:p>
-          <a:p>
-            <a:pPr>
-              <a:spcAft>
-                <a:spcPts val="800"/>
-              </a:spcAft>
-              <a:defRPr sz="1500">
-                <a:solidFill>
-                  <a:srgbClr val="94A3B8"/>
-                </a:solidFill>
-              </a:defRPr>
-            </a:pPr>
-            <a:r>
-              <a:t>No fee for matching — contingency attorneys in network.</a:t>
+              <a:t>In North Carolina, the statute of limitations on most personal-injury claims is 3 years from the date of the crash. Missing that window almost always ends the case — courts dismiss late-filed lawsuits with rare exceptions for minors, mental incapacity, or delayed discovery of injuries. Notice deadlines for claims again</a:t>
             </a:r>
           </a:p>
         </p:txBody>
@@ -5005,7 +5134,7 @@
               </a:defRPr>
             </a:pPr>
             <a:r>
-              <a:t>Reviewed for legal context</a:t>
+              <a:t>Frequently asked questions</a:t>
             </a:r>
           </a:p>
         </p:txBody>
@@ -5043,7 +5172,7 @@
               </a:defRPr>
             </a:pPr>
             <a:r>
-              <a:t>Judge Roy Waddell — Legal Advisor, WreckMatch LLC.</a:t>
+              <a:t>Q: How long do I have to file a commercial-truck crash claim in North Carolina?</a:t>
             </a:r>
           </a:p>
           <a:p>
@@ -5058,7 +5187,7 @@
               </a:defRPr>
             </a:pPr>
             <a:r>
-              <a:t>Courtroom and procedural perspective only.</a:t>
+              <a:t>A: North Carolina sets a 3-year statute of limitations for most personal-injury lawsuits arising from a commercial-truck crash, running from the date of the crash. Notice-of-claim deadlines against government vehicles are usually much shorter — sometimes 60 to 180 days — and minors and incapacitated plaintiffs may have tolled deadlines. Treat the headline number as a ceiling, not a target: file or co</a:t>
             </a:r>
           </a:p>
           <a:p>
@@ -5073,7 +5202,7 @@
               </a:defRPr>
             </a:pPr>
             <a:r>
-              <a:t>Not case-specific legal advice.</a:t>
+              <a:t>Q: How much does it cost to talk to a SemiTruckMatch-network attorney?</a:t>
             </a:r>
           </a:p>
           <a:p>
@@ -5088,7 +5217,52 @@
               </a:defRPr>
             </a:pPr>
             <a:r>
-              <a:t>Guía: https://www.wreckmatch.com/blog/18-wheeler-crash-in-charlotte-north-carolina-victim-guide-2026</a:t>
+              <a:t>A: Nothing up front. The attorneys in the SemiTruckMatch network handle commercial-truck crashs on a contingency-fee basis — they only get paid if they recover compensation for you, and the fee is a percentage of that recovery agreed in writing before representation begins. The initial consultation is free, and there is no obligation to hire the attorney after the call. SemiTruckMatch (operated by Wr</a:t>
+            </a:r>
+          </a:p>
+          <a:p>
+            <a:pPr>
+              <a:spcAft>
+                <a:spcPts val="800"/>
+              </a:spcAft>
+              <a:defRPr sz="1500">
+                <a:solidFill>
+                  <a:srgbClr val="94A3B8"/>
+                </a:solidFill>
+              </a:defRPr>
+            </a:pPr>
+            <a:r>
+              <a:t>Q: What if the other driver was uninsured or fled the scene?</a:t>
+            </a:r>
+          </a:p>
+          <a:p>
+            <a:pPr>
+              <a:spcAft>
+                <a:spcPts val="800"/>
+              </a:spcAft>
+              <a:defRPr sz="1500">
+                <a:solidFill>
+                  <a:srgbClr val="94A3B8"/>
+                </a:solidFill>
+              </a:defRPr>
+            </a:pPr>
+            <a:r>
+              <a:t>A: Roughly 1 in 8 U.S. drivers carries no insurance, and hit-and-run rates are climbing in major metros. If the at-fault driver was uninsured or fled, your own uninsured-motorist (UM) coverage is the primary source of recovery, assuming you carry it. Many drivers don't realize they have UM coverage until a lawyer reviews the declarations page of their policy. If UM is in place, the claim is filed aga</a:t>
+            </a:r>
+          </a:p>
+          <a:p>
+            <a:pPr>
+              <a:spcAft>
+                <a:spcPts val="800"/>
+              </a:spcAft>
+              <a:defRPr sz="1500">
+                <a:solidFill>
+                  <a:srgbClr val="94A3B8"/>
+                </a:solidFill>
+              </a:defRPr>
+            </a:pPr>
+            <a:r>
+              <a:t>Q: Should I give the other driver's insurance a recorded statement?</a:t>
             </a:r>
           </a:p>
         </p:txBody>
@@ -5101,7 +5275,7 @@
 </p:sld>
 </file>
 
-<file path=ppt/slides/slide2.xml><?xml version="1.0" encoding="utf-8"?>
+<file path=ppt/slides/slide13.xml><?xml version="1.0" encoding="utf-8"?>
 <p:sld xmlns:a="http://schemas.openxmlformats.org/drawingml/2006/main" xmlns:p="http://schemas.openxmlformats.org/presentationml/2006/main" xmlns:r="http://schemas.openxmlformats.org/officeDocument/2006/relationships">
   <p:cSld>
     <p:bg>
@@ -5192,7 +5366,7 @@
               </a:defRPr>
             </a:pPr>
             <a:r>
-              <a:t>Important — read first</a:t>
+              <a:t>Get matched with a licensed attorney</a:t>
             </a:r>
           </a:p>
         </p:txBody>
@@ -5230,7 +5404,7 @@
               </a:defRPr>
             </a:pPr>
             <a:r>
-              <a:t>Educational only — not legal advice.</a:t>
+              <a:t>Free attorney matching in ~60 seconds: https://www.wreckmatch.com/#form</a:t>
             </a:r>
           </a:p>
           <a:p>
@@ -5245,7 +5419,7 @@
               </a:defRPr>
             </a:pPr>
             <a:r>
-              <a:t>WreckMatch LLC is a legal referral service, NOT a law firm.</a:t>
+              <a:t>Call 855 WRECKMATCH (855) 897-3256</a:t>
             </a:r>
           </a:p>
           <a:p>
@@ -5260,7 +5434,7 @@
               </a:defRPr>
             </a:pPr>
             <a:r>
-              <a:t>800+ participating law firms nationwide — free matching.</a:t>
+              <a:t>Full article: https://www.wreckmatch.com/blog/18-wheeler-crash-in-charlotte-north-carolina-victim-guide-2026</a:t>
             </a:r>
           </a:p>
           <a:p>
@@ -5275,22 +5449,7 @@
               </a:defRPr>
             </a:pPr>
             <a:r>
-              <a:t>Confirm all deadlines with licensed counsel in your state.</a:t>
-            </a:r>
-          </a:p>
-          <a:p>
-            <a:pPr>
-              <a:spcAft>
-                <a:spcPts val="800"/>
-              </a:spcAft>
-              <a:defRPr sz="1500">
-                <a:solidFill>
-                  <a:srgbClr val="94A3B8"/>
-                </a:solidFill>
-              </a:defRPr>
-            </a:pPr>
-            <a:r>
-              <a:t>Author: Scott Tischler, Co-Founder.</a:t>
+              <a:t>No fee for matching — contingency attorneys in network.</a:t>
             </a:r>
           </a:p>
         </p:txBody>
@@ -5303,7 +5462,7 @@
 </p:sld>
 </file>
 
-<file path=ppt/slides/slide3.xml><?xml version="1.0" encoding="utf-8"?>
+<file path=ppt/slides/slide14.xml><?xml version="1.0" encoding="utf-8"?>
 <p:sld xmlns:a="http://schemas.openxmlformats.org/drawingml/2006/main" xmlns:p="http://schemas.openxmlformats.org/presentationml/2006/main" xmlns:r="http://schemas.openxmlformats.org/officeDocument/2006/relationships">
   <p:cSld>
     <p:bg>
@@ -5394,7 +5553,7 @@
               </a:defRPr>
             </a:pPr>
             <a:r>
-              <a:t>Quick answer (quotable summary)</a:t>
+              <a:t>Reviewed for legal context</a:t>
             </a:r>
           </a:p>
         </p:txBody>
@@ -5432,7 +5591,52 @@
               </a:defRPr>
             </a:pPr>
             <a:r>
-              <a:t>After a semi truck or crash in Charlotte, call 911, get trauma care, preserve evidence including ECM/black box data, avoid recorded insurer statements, and use free attorney matching before signing anything.</a:t>
+              <a:t>Judge Roy Waddell — Legal Advisor, WreckMatch LLC.</a:t>
+            </a:r>
+          </a:p>
+          <a:p>
+            <a:pPr>
+              <a:spcAft>
+                <a:spcPts val="800"/>
+              </a:spcAft>
+              <a:defRPr sz="1500">
+                <a:solidFill>
+                  <a:srgbClr val="94A3B8"/>
+                </a:solidFill>
+              </a:defRPr>
+            </a:pPr>
+            <a:r>
+              <a:t>Courtroom and procedural perspective only.</a:t>
+            </a:r>
+          </a:p>
+          <a:p>
+            <a:pPr>
+              <a:spcAft>
+                <a:spcPts val="800"/>
+              </a:spcAft>
+              <a:defRPr sz="1500">
+                <a:solidFill>
+                  <a:srgbClr val="94A3B8"/>
+                </a:solidFill>
+              </a:defRPr>
+            </a:pPr>
+            <a:r>
+              <a:t>Not case-specific legal advice.</a:t>
+            </a:r>
+          </a:p>
+          <a:p>
+            <a:pPr>
+              <a:spcAft>
+                <a:spcPts val="800"/>
+              </a:spcAft>
+              <a:defRPr sz="1500">
+                <a:solidFill>
+                  <a:srgbClr val="94A3B8"/>
+                </a:solidFill>
+              </a:defRPr>
+            </a:pPr>
+            <a:r>
+              <a:t>Guía: https://www.wreckmatch.com/blog/18-wheeler-crash-in-charlotte-north-carolina-victim-guide-2026</a:t>
             </a:r>
           </a:p>
         </p:txBody>
@@ -5445,7 +5649,7 @@
 </p:sld>
 </file>
 
-<file path=ppt/slides/slide4.xml><?xml version="1.0" encoding="utf-8"?>
+<file path=ppt/slides/slide2.xml><?xml version="1.0" encoding="utf-8"?>
 <p:sld xmlns:a="http://schemas.openxmlformats.org/drawingml/2006/main" xmlns:p="http://schemas.openxmlformats.org/presentationml/2006/main" xmlns:r="http://schemas.openxmlformats.org/officeDocument/2006/relationships">
   <p:cSld>
     <p:bg>
@@ -5536,7 +5740,7 @@
               </a:defRPr>
             </a:pPr>
             <a:r>
-              <a:t>Why we published this guide for Charlotte</a:t>
+              <a:t>Important — read first</a:t>
             </a:r>
           </a:p>
         </p:txBody>
@@ -5574,7 +5778,67 @@
               </a:defRPr>
             </a:pPr>
             <a:r>
-              <a:t>Insurance companies run billion-dollar playbooks the moment a crash is reported — trained adjusters, scripted calls, and pressure to settle before you understand your rights. Scott Tischler, Co-Founder of WreckMatch, built our AI intake and educational stack so everyday drivers in North Carolina are not outgunned. This</a:t>
+              <a:t>Educational only — not legal advice.</a:t>
+            </a:r>
+          </a:p>
+          <a:p>
+            <a:pPr>
+              <a:spcAft>
+                <a:spcPts val="800"/>
+              </a:spcAft>
+              <a:defRPr sz="1500">
+                <a:solidFill>
+                  <a:srgbClr val="94A3B8"/>
+                </a:solidFill>
+              </a:defRPr>
+            </a:pPr>
+            <a:r>
+              <a:t>WreckMatch LLC is a legal referral service, NOT a law firm.</a:t>
+            </a:r>
+          </a:p>
+          <a:p>
+            <a:pPr>
+              <a:spcAft>
+                <a:spcPts val="800"/>
+              </a:spcAft>
+              <a:defRPr sz="1500">
+                <a:solidFill>
+                  <a:srgbClr val="94A3B8"/>
+                </a:solidFill>
+              </a:defRPr>
+            </a:pPr>
+            <a:r>
+              <a:t>800+ participating law firms nationwide — free matching.</a:t>
+            </a:r>
+          </a:p>
+          <a:p>
+            <a:pPr>
+              <a:spcAft>
+                <a:spcPts val="800"/>
+              </a:spcAft>
+              <a:defRPr sz="1500">
+                <a:solidFill>
+                  <a:srgbClr val="94A3B8"/>
+                </a:solidFill>
+              </a:defRPr>
+            </a:pPr>
+            <a:r>
+              <a:t>Confirm all deadlines with licensed counsel in your state.</a:t>
+            </a:r>
+          </a:p>
+          <a:p>
+            <a:pPr>
+              <a:spcAft>
+                <a:spcPts val="800"/>
+              </a:spcAft>
+              <a:defRPr sz="1500">
+                <a:solidFill>
+                  <a:srgbClr val="94A3B8"/>
+                </a:solidFill>
+              </a:defRPr>
+            </a:pPr>
+            <a:r>
+              <a:t>Author: Scott Tischler, Co-Founder.</a:t>
             </a:r>
           </a:p>
         </p:txBody>
@@ -5587,7 +5851,7 @@
 </p:sld>
 </file>
 
-<file path=ppt/slides/slide5.xml><?xml version="1.0" encoding="utf-8"?>
+<file path=ppt/slides/slide3.xml><?xml version="1.0" encoding="utf-8"?>
 <p:sld xmlns:a="http://schemas.openxmlformats.org/drawingml/2006/main" xmlns:p="http://schemas.openxmlformats.org/presentationml/2006/main" xmlns:r="http://schemas.openxmlformats.org/officeDocument/2006/relationships">
   <p:cSld>
     <p:bg>
@@ -5678,7 +5942,7 @@
               </a:defRPr>
             </a:pPr>
             <a:r>
-              <a:t>What should you do first?</a:t>
+              <a:t>Quick answer (quotable summary)</a:t>
             </a:r>
           </a:p>
         </p:txBody>
@@ -5716,82 +5980,7 @@
               </a:defRPr>
             </a:pPr>
             <a:r>
-              <a:t>Call 911 — truck crashes often need highway patrol + EMS.</a:t>
-            </a:r>
-          </a:p>
-          <a:p>
-            <a:pPr>
-              <a:spcAft>
-                <a:spcPts val="800"/>
-              </a:spcAft>
-              <a:defRPr sz="1500">
-                <a:solidFill>
-                  <a:srgbClr val="94A3B8"/>
-                </a:solidFill>
-              </a:defRPr>
-            </a:pPr>
-            <a:r>
-              <a:t>Photograph all vehicles, DOT numbers, plates, and scene marks.</a:t>
-            </a:r>
-          </a:p>
-          <a:p>
-            <a:pPr>
-              <a:spcAft>
-                <a:spcPts val="800"/>
-              </a:spcAft>
-              <a:defRPr sz="1500">
-                <a:solidFill>
-                  <a:srgbClr val="94A3B8"/>
-                </a:solidFill>
-              </a:defRPr>
-            </a:pPr>
-            <a:r>
-              <a:t>Identify carrier name on the tractor/trailer door.</a:t>
-            </a:r>
-          </a:p>
-          <a:p>
-            <a:pPr>
-              <a:spcAft>
-                <a:spcPts val="800"/>
-              </a:spcAft>
-              <a:defRPr sz="1500">
-                <a:solidFill>
-                  <a:srgbClr val="94A3B8"/>
-                </a:solidFill>
-              </a:defRPr>
-            </a:pPr>
-            <a:r>
-              <a:t>Seek trauma care — severe injuries may not show on X-ray day one.</a:t>
-            </a:r>
-          </a:p>
-          <a:p>
-            <a:pPr>
-              <a:spcAft>
-                <a:spcPts val="800"/>
-              </a:spcAft>
-              <a:defRPr sz="1500">
-                <a:solidFill>
-                  <a:srgbClr val="94A3B8"/>
-                </a:solidFill>
-              </a:defRPr>
-            </a:pPr>
-            <a:r>
-              <a:t>Do not give a recorded statement to any insurer.</a:t>
-            </a:r>
-          </a:p>
-          <a:p>
-            <a:pPr>
-              <a:spcAft>
-                <a:spcPts val="800"/>
-              </a:spcAft>
-              <a:defRPr sz="1500">
-                <a:solidFill>
-                  <a:srgbClr val="94A3B8"/>
-                </a:solidFill>
-              </a:defRPr>
-            </a:pPr>
-            <a:r>
-              <a:t>Get matched with a lawyer →</a:t>
+              <a:t>After a semi truck or crash in Charlotte, North Carolina, call 911, get medical care, preserve evidence including ECM/black box and carrier IDs, avoid recorded insurer statements, and use free attorney matching before signing anything.</a:t>
             </a:r>
           </a:p>
         </p:txBody>
@@ -5804,7 +5993,7 @@
 </p:sld>
 </file>
 
-<file path=ppt/slides/slide6.xml><?xml version="1.0" encoding="utf-8"?>
+<file path=ppt/slides/slide4.xml><?xml version="1.0" encoding="utf-8"?>
 <p:sld xmlns:a="http://schemas.openxmlformats.org/drawingml/2006/main" xmlns:p="http://schemas.openxmlformats.org/presentationml/2006/main" xmlns:r="http://schemas.openxmlformats.org/officeDocument/2006/relationships">
   <p:cSld>
     <p:bg>
@@ -5895,7 +6084,7 @@
               </a:defRPr>
             </a:pPr>
             <a:r>
-              <a:t>Semi truck &amp; commercial vehicle specifics</a:t>
+              <a:t>Why we published this guide for Charlotte</a:t>
             </a:r>
           </a:p>
         </p:txBody>
@@ -5933,67 +6122,7 @@
               </a:defRPr>
             </a:pPr>
             <a:r>
-              <a:t>Evidence · Why it matters</a:t>
-            </a:r>
-          </a:p>
-          <a:p>
-            <a:pPr>
-              <a:spcAft>
-                <a:spcPts val="800"/>
-              </a:spcAft>
-              <a:defRPr sz="1500">
-                <a:solidFill>
-                  <a:srgbClr val="94A3B8"/>
-                </a:solidFill>
-              </a:defRPr>
-            </a:pPr>
-            <a:r>
-              <a:t>Black box (ECM) data · Speed, braking, hours-of-service</a:t>
-            </a:r>
-          </a:p>
-          <a:p>
-            <a:pPr>
-              <a:spcAft>
-                <a:spcPts val="800"/>
-              </a:spcAft>
-              <a:defRPr sz="1500">
-                <a:solidFill>
-                  <a:srgbClr val="94A3B8"/>
-                </a:solidFill>
-              </a:defRPr>
-            </a:pPr>
-            <a:r>
-              <a:t>Driver logbooks / ELD · FMCSA violations</a:t>
-            </a:r>
-          </a:p>
-          <a:p>
-            <a:pPr>
-              <a:spcAft>
-                <a:spcPts val="800"/>
-              </a:spcAft>
-              <a:defRPr sz="1500">
-                <a:solidFill>
-                  <a:srgbClr val="94A3B8"/>
-                </a:solidFill>
-              </a:defRPr>
-            </a:pPr>
-            <a:r>
-              <a:t>Cargo loading records · Shifted load liability</a:t>
-            </a:r>
-          </a:p>
-          <a:p>
-            <a:pPr>
-              <a:spcAft>
-                <a:spcPts val="800"/>
-              </a:spcAft>
-              <a:defRPr sz="1500">
-                <a:solidFill>
-                  <a:srgbClr val="94A3B8"/>
-                </a:solidFill>
-              </a:defRPr>
-            </a:pPr>
-            <a:r>
-              <a:t>Carrier insurance limits · Often $750K–$1M+</a:t>
+              <a:t>Insurance companies run billion-dollar playbooks the moment a crash is reported — trained adjusters, scripted calls, and pressure to settle before you understand your rights. Scott Tischler, Co-Founder of WreckMatch, built our AI intake and educational stack so semi-truck crash victims in North Carolina are not outgunn</a:t>
             </a:r>
           </a:p>
         </p:txBody>
@@ -6006,7 +6135,7 @@
 </p:sld>
 </file>
 
-<file path=ppt/slides/slide7.xml><?xml version="1.0" encoding="utf-8"?>
+<file path=ppt/slides/slide5.xml><?xml version="1.0" encoding="utf-8"?>
 <p:sld xmlns:a="http://schemas.openxmlformats.org/drawingml/2006/main" xmlns:p="http://schemas.openxmlformats.org/presentationml/2006/main" xmlns:r="http://schemas.openxmlformats.org/officeDocument/2006/relationships">
   <p:cSld>
     <p:bg>
@@ -6097,7 +6226,7 @@
               </a:defRPr>
             </a:pPr>
             <a:r>
-              <a:t>North Carolina deadlines</a:t>
+              <a:t>What should you do first after a truck crash in Charlotte?</a:t>
             </a:r>
           </a:p>
         </p:txBody>
@@ -6135,7 +6264,7 @@
               </a:defRPr>
             </a:pPr>
             <a:r>
-              <a:t>Topic · Detail</a:t>
+              <a:t>Call 911 — commercial crashes often need highway patrol, HAZMAT, and EMS.</a:t>
             </a:r>
           </a:p>
           <a:p>
@@ -6150,7 +6279,7 @@
               </a:defRPr>
             </a:pPr>
             <a:r>
-              <a:t>Statute of limitations · 3 years (most injury claims — confirm with licensed counsel) (many claims)</a:t>
+              <a:t>Photograph all units, DOT numbers, plates, carrier logos, and road conditions.</a:t>
             </a:r>
           </a:p>
           <a:p>
@@ -6165,7 +6294,52 @@
               </a:defRPr>
             </a:pPr>
             <a:r>
-              <a:t>WreckMatch fee · $0 matching</a:t>
+              <a:t>Request driver and carrier identification (many defendants may exist).</a:t>
+            </a:r>
+          </a:p>
+          <a:p>
+            <a:pPr>
+              <a:spcAft>
+                <a:spcPts val="800"/>
+              </a:spcAft>
+              <a:defRPr sz="1500">
+                <a:solidFill>
+                  <a:srgbClr val="94A3B8"/>
+                </a:solidFill>
+              </a:defRPr>
+            </a:pPr>
+            <a:r>
+              <a:t>Seek trauma care — internal injuries are common even when you feel “fine.”</a:t>
+            </a:r>
+          </a:p>
+          <a:p>
+            <a:pPr>
+              <a:spcAft>
+                <a:spcPts val="800"/>
+              </a:spcAft>
+              <a:defRPr sz="1500">
+                <a:solidFill>
+                  <a:srgbClr val="94A3B8"/>
+                </a:solidFill>
+              </a:defRPr>
+            </a:pPr>
+            <a:r>
+              <a:t>Do not give a recorded statement to any insurer.</a:t>
+            </a:r>
+          </a:p>
+          <a:p>
+            <a:pPr>
+              <a:spcAft>
+                <a:spcPts val="800"/>
+              </a:spcAft>
+              <a:defRPr sz="1500">
+                <a:solidFill>
+                  <a:srgbClr val="94A3B8"/>
+                </a:solidFill>
+              </a:defRPr>
+            </a:pPr>
+            <a:r>
+              <a:t>Get matched with a lawyer →</a:t>
             </a:r>
           </a:p>
         </p:txBody>
@@ -6178,7 +6352,7 @@
 </p:sld>
 </file>
 
-<file path=ppt/slides/slide8.xml><?xml version="1.0" encoding="utf-8"?>
+<file path=ppt/slides/slide6.xml><?xml version="1.0" encoding="utf-8"?>
 <p:sld xmlns:a="http://schemas.openxmlformats.org/drawingml/2006/main" xmlns:p="http://schemas.openxmlformats.org/presentationml/2006/main" xmlns:r="http://schemas.openxmlformats.org/officeDocument/2006/relationships">
   <p:cSld>
     <p:bg>
@@ -6269,7 +6443,7 @@
               </a:defRPr>
             </a:pPr>
             <a:r>
-              <a:t>Insurance tactics</a:t>
+              <a:t>Semi truck &amp; commercial vehicle specifics</a:t>
             </a:r>
           </a:p>
         </p:txBody>
@@ -6307,7 +6481,7 @@
               </a:defRPr>
             </a:pPr>
             <a:r>
-              <a:t>Rushing low settlements before surgery/MRI results</a:t>
+              <a:t>Evidence · Why it matters</a:t>
             </a:r>
           </a:p>
           <a:p>
@@ -6322,7 +6496,7 @@
               </a:defRPr>
             </a:pPr>
             <a:r>
-              <a:t>Disputing serious injury thresholds</a:t>
+              <a:t>Black box (ECM) data · Speed, braking, hours-of-service</a:t>
             </a:r>
           </a:p>
           <a:p>
@@ -6337,7 +6511,37 @@
               </a:defRPr>
             </a:pPr>
             <a:r>
-              <a:t>Multiple insurers pointing blame at each other (common in truck cases)</a:t>
+              <a:t>Driver logbooks / ELD · FMCSA violations</a:t>
+            </a:r>
+          </a:p>
+          <a:p>
+            <a:pPr>
+              <a:spcAft>
+                <a:spcPts val="800"/>
+              </a:spcAft>
+              <a:defRPr sz="1500">
+                <a:solidFill>
+                  <a:srgbClr val="94A3B8"/>
+                </a:solidFill>
+              </a:defRPr>
+            </a:pPr>
+            <a:r>
+              <a:t>Cargo loading records · Shifted load liability</a:t>
+            </a:r>
+          </a:p>
+          <a:p>
+            <a:pPr>
+              <a:spcAft>
+                <a:spcPts val="800"/>
+              </a:spcAft>
+              <a:defRPr sz="1500">
+                <a:solidFill>
+                  <a:srgbClr val="94A3B8"/>
+                </a:solidFill>
+              </a:defRPr>
+            </a:pPr>
+            <a:r>
+              <a:t>Carrier insurance limits · Often $750K–$1M+</a:t>
             </a:r>
           </a:p>
         </p:txBody>
@@ -6350,7 +6554,7 @@
 </p:sld>
 </file>
 
-<file path=ppt/slides/slide9.xml><?xml version="1.0" encoding="utf-8"?>
+<file path=ppt/slides/slide7.xml><?xml version="1.0" encoding="utf-8"?>
 <p:sld xmlns:a="http://schemas.openxmlformats.org/drawingml/2006/main" xmlns:p="http://schemas.openxmlformats.org/presentationml/2006/main" xmlns:r="http://schemas.openxmlformats.org/officeDocument/2006/relationships">
   <p:cSld>
     <p:bg>
@@ -6441,7 +6645,7 @@
               </a:defRPr>
             </a:pPr>
             <a:r>
-              <a:t>FAQ</a:t>
+              <a:t>North Carolina deadlines &amp; why timing matters</a:t>
             </a:r>
           </a:p>
         </p:txBody>
@@ -6479,7 +6683,7 @@
               </a:defRPr>
             </a:pPr>
             <a:r>
-              <a:t>Q: Does WreckMatch have truck accident lawyers?</a:t>
+              <a:t>Topic · Detail</a:t>
             </a:r>
           </a:p>
           <a:p>
@@ -6494,7 +6698,7 @@
               </a:defRPr>
             </a:pPr>
             <a:r>
-              <a:t>A: We refer to participating attorneys who handle car, truck, and catastrophic injury matters in North Carolina.</a:t>
+              <a:t>Statute of limitations · 3 years (most injury claims — confirm with licensed counsel)</a:t>
             </a:r>
           </a:p>
           <a:p>
@@ -6509,7 +6713,7 @@
               </a:defRPr>
             </a:pPr>
             <a:r>
-              <a:t>Q: How fast is callback?</a:t>
+              <a:t>Government / special defendants · Often much shorter notice windows — ask counsel immediately</a:t>
             </a:r>
           </a:p>
           <a:p>
@@ -6524,9 +6728,136 @@
               </a:defRPr>
             </a:pPr>
             <a:r>
-              <a:t>A: Typically under 60 seconds at wreckmatch.com.</a:t>
-            </a:r>
-          </a:p>
+              <a:t>SemiTruckMatch matching fee · $0 to consumers</a:t>
+            </a:r>
+          </a:p>
+        </p:txBody>
+      </p:sp>
+    </p:spTree>
+  </p:cSld>
+  <p:clrMapOvr>
+    <a:masterClrMapping/>
+  </p:clrMapOvr>
+</p:sld>
+</file>
+
+<file path=ppt/slides/slide8.xml><?xml version="1.0" encoding="utf-8"?>
+<p:sld xmlns:a="http://schemas.openxmlformats.org/drawingml/2006/main" xmlns:p="http://schemas.openxmlformats.org/presentationml/2006/main" xmlns:r="http://schemas.openxmlformats.org/officeDocument/2006/relationships">
+  <p:cSld>
+    <p:bg>
+      <p:bgPr>
+        <a:solidFill>
+          <a:srgbClr val="0F172A"/>
+        </a:solidFill>
+        <a:effectLst/>
+      </p:bgPr>
+    </p:bg>
+    <p:spTree>
+      <p:nvGrpSpPr>
+        <p:cNvPr id="1" name=""/>
+        <p:cNvGrpSpPr/>
+        <p:nvPr/>
+      </p:nvGrpSpPr>
+      <p:grpSpPr/>
+      <p:sp>
+        <p:nvSpPr>
+          <p:cNvPr id="2" name="Rectangle 1"/>
+          <p:cNvSpPr/>
+          <p:nvPr/>
+        </p:nvSpPr>
+        <p:spPr>
+          <a:xfrm>
+            <a:off x="0" y="0"/>
+            <a:ext cx="109728" cy="6858000"/>
+          </a:xfrm>
+          <a:prstGeom prst="rect">
+            <a:avLst/>
+          </a:prstGeom>
+          <a:solidFill>
+            <a:srgbClr val="CC0000"/>
+          </a:solidFill>
+          <a:ln>
+            <a:noFill/>
+          </a:ln>
+        </p:spPr>
+        <p:style>
+          <a:lnRef idx="1">
+            <a:schemeClr val="accent1"/>
+          </a:lnRef>
+          <a:fillRef idx="3">
+            <a:schemeClr val="accent1"/>
+          </a:fillRef>
+          <a:effectRef idx="2">
+            <a:schemeClr val="accent1"/>
+          </a:effectRef>
+          <a:fontRef idx="minor">
+            <a:schemeClr val="lt1"/>
+          </a:fontRef>
+        </p:style>
+        <p:txBody>
+          <a:bodyPr rtlCol="0" anchor="ctr"/>
+          <a:lstStyle/>
+          <a:p>
+            <a:pPr algn="ctr"/>
+          </a:p>
+        </p:txBody>
+      </p:sp>
+      <p:sp>
+        <p:nvSpPr>
+          <p:cNvPr id="3" name="TextBox 2"/>
+          <p:cNvSpPr txBox="1"/>
+          <p:nvPr/>
+        </p:nvSpPr>
+        <p:spPr>
+          <a:xfrm>
+            <a:off x="411480" y="411480"/>
+            <a:ext cx="8229600" cy="822960"/>
+          </a:xfrm>
+          <a:prstGeom prst="rect">
+            <a:avLst/>
+          </a:prstGeom>
+          <a:noFill/>
+        </p:spPr>
+        <p:txBody>
+          <a:bodyPr wrap="none">
+            <a:spAutoFit/>
+          </a:bodyPr>
+          <a:lstStyle/>
+          <a:p>
+            <a:pPr>
+              <a:defRPr sz="2400" b="1">
+                <a:solidFill>
+                  <a:srgbClr val="FFFFFF"/>
+                </a:solidFill>
+              </a:defRPr>
+            </a:pPr>
+            <a:r>
+              <a:t>Insurance company tactics to expect</a:t>
+            </a:r>
+          </a:p>
+        </p:txBody>
+      </p:sp>
+      <p:sp>
+        <p:nvSpPr>
+          <p:cNvPr id="4" name="TextBox 3"/>
+          <p:cNvSpPr txBox="1"/>
+          <p:nvPr/>
+        </p:nvSpPr>
+        <p:spPr>
+          <a:xfrm>
+            <a:off x="502920" y="1234440"/>
+            <a:ext cx="8138160" cy="5029200"/>
+          </a:xfrm>
+          <a:prstGeom prst="rect">
+            <a:avLst/>
+          </a:prstGeom>
+          <a:noFill/>
+        </p:spPr>
+        <p:txBody>
+          <a:bodyPr wrap="square">
+            <a:spAutoFit/>
+          </a:bodyPr>
+          <a:lstStyle/>
           <a:p>
             <a:pPr>
               <a:spcAft>
@@ -6539,7 +6870,7 @@
               </a:defRPr>
             </a:pPr>
             <a:r>
-              <a:t>Q: Full Charlotte guide</a:t>
+              <a:t>Recorded statements in the first 24–48 hours designed to lock in fault language</a:t>
             </a:r>
           </a:p>
           <a:p>
@@ -6554,17 +6885,179 @@
               </a:defRPr>
             </a:pPr>
             <a:r>
-              <a:t>A: Charlotte help hub</a:t>
-            </a:r>
-            <a:br/>
-            <a:br/>
-            <a:r>
-              <a:t>Free attorney matching → · 855 WRECKMATCH (855) 897-3256</a:t>
-            </a:r>
-            <a:br/>
-            <a:br/>
-            <a:r>
-              <a:t>---</a:t>
+              <a:t>Quick cash offers before MRI results or specialist referrals return</a:t>
+            </a:r>
+          </a:p>
+          <a:p>
+            <a:pPr>
+              <a:spcAft>
+                <a:spcPts val="800"/>
+              </a:spcAft>
+              <a:defRPr sz="1500">
+                <a:solidFill>
+                  <a:srgbClr val="94A3B8"/>
+                </a:solidFill>
+              </a:defRPr>
+            </a:pPr>
+            <a:r>
+              <a:t>Disputing serious injury thresholds or pre-existing conditions</a:t>
+            </a:r>
+          </a:p>
+          <a:p>
+            <a:pPr>
+              <a:spcAft>
+                <a:spcPts val="800"/>
+              </a:spcAft>
+              <a:defRPr sz="1500">
+                <a:solidFill>
+                  <a:srgbClr val="94A3B8"/>
+                </a:solidFill>
+              </a:defRPr>
+            </a:pPr>
+            <a:r>
+              <a:t>Multiple policies pointing blame at each other (especially in truck and multi-vehicle crashes)</a:t>
+            </a:r>
+          </a:p>
+        </p:txBody>
+      </p:sp>
+    </p:spTree>
+  </p:cSld>
+  <p:clrMapOvr>
+    <a:masterClrMapping/>
+  </p:clrMapOvr>
+</p:sld>
+</file>
+
+<file path=ppt/slides/slide9.xml><?xml version="1.0" encoding="utf-8"?>
+<p:sld xmlns:a="http://schemas.openxmlformats.org/drawingml/2006/main" xmlns:p="http://schemas.openxmlformats.org/presentationml/2006/main" xmlns:r="http://schemas.openxmlformats.org/officeDocument/2006/relationships">
+  <p:cSld>
+    <p:bg>
+      <p:bgPr>
+        <a:solidFill>
+          <a:srgbClr val="0F172A"/>
+        </a:solidFill>
+        <a:effectLst/>
+      </p:bgPr>
+    </p:bg>
+    <p:spTree>
+      <p:nvGrpSpPr>
+        <p:cNvPr id="1" name=""/>
+        <p:cNvGrpSpPr/>
+        <p:nvPr/>
+      </p:nvGrpSpPr>
+      <p:grpSpPr/>
+      <p:sp>
+        <p:nvSpPr>
+          <p:cNvPr id="2" name="Rectangle 1"/>
+          <p:cNvSpPr/>
+          <p:nvPr/>
+        </p:nvSpPr>
+        <p:spPr>
+          <a:xfrm>
+            <a:off x="0" y="0"/>
+            <a:ext cx="109728" cy="6858000"/>
+          </a:xfrm>
+          <a:prstGeom prst="rect">
+            <a:avLst/>
+          </a:prstGeom>
+          <a:solidFill>
+            <a:srgbClr val="CC0000"/>
+          </a:solidFill>
+          <a:ln>
+            <a:noFill/>
+          </a:ln>
+        </p:spPr>
+        <p:style>
+          <a:lnRef idx="1">
+            <a:schemeClr val="accent1"/>
+          </a:lnRef>
+          <a:fillRef idx="3">
+            <a:schemeClr val="accent1"/>
+          </a:fillRef>
+          <a:effectRef idx="2">
+            <a:schemeClr val="accent1"/>
+          </a:effectRef>
+          <a:fontRef idx="minor">
+            <a:schemeClr val="lt1"/>
+          </a:fontRef>
+        </p:style>
+        <p:txBody>
+          <a:bodyPr rtlCol="0" anchor="ctr"/>
+          <a:lstStyle/>
+          <a:p>
+            <a:pPr algn="ctr"/>
+          </a:p>
+        </p:txBody>
+      </p:sp>
+      <p:sp>
+        <p:nvSpPr>
+          <p:cNvPr id="3" name="TextBox 2"/>
+          <p:cNvSpPr txBox="1"/>
+          <p:nvPr/>
+        </p:nvSpPr>
+        <p:spPr>
+          <a:xfrm>
+            <a:off x="411480" y="411480"/>
+            <a:ext cx="8229600" cy="822960"/>
+          </a:xfrm>
+          <a:prstGeom prst="rect">
+            <a:avLst/>
+          </a:prstGeom>
+          <a:noFill/>
+        </p:spPr>
+        <p:txBody>
+          <a:bodyPr wrap="none">
+            <a:spAutoFit/>
+          </a:bodyPr>
+          <a:lstStyle/>
+          <a:p>
+            <a:pPr>
+              <a:defRPr sz="2400" b="1">
+                <a:solidFill>
+                  <a:srgbClr val="FFFFFF"/>
+                </a:solidFill>
+              </a:defRPr>
+            </a:pPr>
+            <a:r>
+              <a:t>When to speak with a lawyer</a:t>
+            </a:r>
+          </a:p>
+        </p:txBody>
+      </p:sp>
+      <p:sp>
+        <p:nvSpPr>
+          <p:cNvPr id="4" name="TextBox 3"/>
+          <p:cNvSpPr txBox="1"/>
+          <p:nvPr/>
+        </p:nvSpPr>
+        <p:spPr>
+          <a:xfrm>
+            <a:off x="502920" y="1234440"/>
+            <a:ext cx="8138160" cy="5029200"/>
+          </a:xfrm>
+          <a:prstGeom prst="rect">
+            <a:avLst/>
+          </a:prstGeom>
+          <a:noFill/>
+        </p:spPr>
+        <p:txBody>
+          <a:bodyPr wrap="square">
+            <a:spAutoFit/>
+          </a:bodyPr>
+          <a:lstStyle/>
+          <a:p>
+            <a:pPr>
+              <a:spcAft>
+                <a:spcPts val="800"/>
+              </a:spcAft>
+              <a:defRPr sz="1500">
+                <a:solidFill>
+                  <a:srgbClr val="94A3B8"/>
+                </a:solidFill>
+              </a:defRPr>
+            </a:pPr>
+            <a:r>
+              <a:t>Consider a free consultation if: hospitalization occurred, fault is disputed, a commercial truck was involved, a death occurred, or an insurer already denied coverage. SemiTruckMatch connects you with participating licensed attorneys — we do not provide legal advice ourselves.</a:t>
             </a:r>
           </a:p>
         </p:txBody>

</xml_diff>